<commit_message>
Raise chart labels on slide nine
</commit_message>
<xml_diff>
--- a/docs/final_presentation/Handwashing_Final_Presentation.pptx
+++ b/docs/final_presentation/Handwashing_Final_Presentation.pptx
@@ -4882,7 +4882,7 @@
 </file>
 
 <file path=ppt/slides/charts/chart2.xml><?xml version="1.0" encoding="utf-8"?>
-<c:chartSpace xmlns:c="http://schemas.openxmlformats.org/drawingml/2006/chart" xmlns:r="http://schemas.openxmlformats.org/officeDocument/2006/relationships">
+<c:chartSpace xmlns:a="http://schemas.openxmlformats.org/drawingml/2006/main" xmlns:c="http://schemas.openxmlformats.org/drawingml/2006/chart" xmlns:ns2="http://schemas.openxmlformats.org/officeDocument/2006/relationships">
   <c:lang val="en-US"/>
   <c:chart>
     <c:plotArea>
@@ -4897,7 +4897,7 @@
             <c:v>Matched videos</c:v>
           </c:tx>
           <c:spPr>
-            <a:solidFill xmlns:a="http://schemas.openxmlformats.org/drawingml/2006/main">
+            <a:solidFill>
               <a:srgbClr val="22785F"/>
             </a:solidFill>
           </c:spPr>
@@ -4906,7 +4906,7 @@
             <c:idx val="0"/>
             <c:invertIfNegative val="0"/>
             <c:spPr>
-              <a:solidFill xmlns:a="http://schemas.openxmlformats.org/drawingml/2006/main">
+              <a:solidFill>
                 <a:srgbClr val="94B6A2"/>
               </a:solidFill>
             </c:spPr>
@@ -4915,7 +4915,7 @@
             <c:idx val="1"/>
             <c:invertIfNegative val="0"/>
             <c:spPr>
-              <a:solidFill xmlns:a="http://schemas.openxmlformats.org/drawingml/2006/main">
+              <a:solidFill>
                 <a:srgbClr val="5E9B87"/>
               </a:solidFill>
             </c:spPr>
@@ -4924,7 +4924,7 @@
             <c:idx val="2"/>
             <c:invertIfNegative val="0"/>
             <c:spPr>
-              <a:solidFill xmlns:a="http://schemas.openxmlformats.org/drawingml/2006/main">
+              <a:solidFill>
                 <a:srgbClr val="22785F"/>
               </a:solidFill>
             </c:spPr>
@@ -4933,7 +4933,7 @@
             <c:idx val="3"/>
             <c:invertIfNegative val="0"/>
             <c:spPr>
-              <a:solidFill xmlns:a="http://schemas.openxmlformats.org/drawingml/2006/main">
+              <a:solidFill>
                 <a:srgbClr val="8C80A8"/>
               </a:solidFill>
             </c:spPr>
@@ -4983,9 +4983,9 @@
         <c:dLbls>
           <c:numFmt formatCode="0" sourceLinked="0"/>
           <c:txPr>
-            <a:bodyPr xmlns:a="http://schemas.openxmlformats.org/drawingml/2006/main" anchorCtr="1"/>
-            <a:lstStyle xmlns:a="http://schemas.openxmlformats.org/drawingml/2006/main"/>
-            <a:p xmlns:a="http://schemas.openxmlformats.org/drawingml/2006/main">
+            <a:bodyPr anchorCtr="1"/>
+            <a:lstStyle/>
+            <a:p>
               <a:pPr>
                 <a:defRPr sz="1950" b="1">
                   <a:solidFill>
@@ -5000,7 +5000,7 @@
           </c:txPr>
           <c:dLblPos val="outEnd"/>
           <c:showLegendKey val="0"/>
-          <c:showVal val="1"/>
+          <c:showVal val="0"/>
           <c:showCatName val="0"/>
           <c:showSerName val="0"/>
           <c:showPercent val="0"/>
@@ -5022,16 +5022,16 @@
         <c:majorTickMark val="none"/>
         <c:minorTickMark val="none"/>
         <c:spPr>
-          <a:ln xmlns:a="http://schemas.openxmlformats.org/drawingml/2006/main" w="9525">
+          <a:ln w="9525">
             <a:solidFill>
               <a:srgbClr val="63796E"/>
             </a:solidFill>
           </a:ln>
         </c:spPr>
         <c:txPr>
-          <a:bodyPr xmlns:a="http://schemas.openxmlformats.org/drawingml/2006/main" anchorCtr="1"/>
-          <a:lstStyle xmlns:a="http://schemas.openxmlformats.org/drawingml/2006/main"/>
-          <a:p xmlns:a="http://schemas.openxmlformats.org/drawingml/2006/main">
+          <a:bodyPr anchorCtr="1"/>
+          <a:lstStyle/>
+          <a:p>
             <a:pPr>
               <a:defRPr sz="1575">
                 <a:solidFill>
@@ -5057,7 +5057,7 @@
         <c:axPos val="l"/>
         <c:majorGridlines>
           <c:spPr>
-            <a:ln xmlns:a="http://schemas.openxmlformats.org/drawingml/2006/main" w="9525">
+            <a:ln w="9525">
               <a:solidFill>
                 <a:srgbClr val="D5DED4"/>
               </a:solidFill>
@@ -5068,14 +5068,14 @@
         <c:majorTickMark val="none"/>
         <c:minorTickMark val="none"/>
         <c:spPr>
-          <a:ln xmlns:a="http://schemas.openxmlformats.org/drawingml/2006/main" w="0">
+          <a:ln w="0">
             <a:noFill/>
           </a:ln>
         </c:spPr>
         <c:txPr>
-          <a:bodyPr xmlns:a="http://schemas.openxmlformats.org/drawingml/2006/main" anchorCtr="1"/>
-          <a:lstStyle xmlns:a="http://schemas.openxmlformats.org/drawingml/2006/main"/>
-          <a:p xmlns:a="http://schemas.openxmlformats.org/drawingml/2006/main">
+          <a:bodyPr anchorCtr="1"/>
+          <a:lstStyle/>
+          <a:p>
             <a:pPr>
               <a:defRPr sz="1500">
                 <a:solidFill>
@@ -5093,18 +5093,18 @@
         <c:majorUnit val="2"/>
       </c:valAx>
       <c:spPr>
-        <a:noFill xmlns:a="http://schemas.openxmlformats.org/drawingml/2006/main"/>
+        <a:noFill/>
       </c:spPr>
     </c:plotArea>
     <c:plotVisOnly val="1"/>
   </c:chart>
   <c:spPr>
-    <a:noFill xmlns:a="http://schemas.openxmlformats.org/drawingml/2006/main"/>
-    <a:ln xmlns:a="http://schemas.openxmlformats.org/drawingml/2006/main" w="0">
+    <a:noFill/>
+    <a:ln w="0">
       <a:noFill/>
     </a:ln>
   </c:spPr>
-  <c:externalData r:id="rIdChartSnapshot1">
+  <c:externalData ns2:id="rIdChartSnapshot1">
     <c:autoUpdate val="0"/>
   </c:externalData>
 </c:chartSpace>
@@ -20563,11 +20563,11 @@
 </file>
 
 <file path=ppt/slides/slide9.xml><?xml version="1.0" encoding="utf-8"?>
-<p:sld xmlns:p="http://schemas.openxmlformats.org/presentationml/2006/main">
+<p:sld xmlns:a="http://schemas.openxmlformats.org/drawingml/2006/main" xmlns:c="http://schemas.openxmlformats.org/drawingml/2006/chart" xmlns:ns2="http://schemas.microsoft.com/office/drawing/2014/main" xmlns:ns4="http://schemas.openxmlformats.org/officeDocument/2006/relationships" xmlns:ns5="http://schemas.microsoft.com/office/powerpoint/2010/main" xmlns:p="http://schemas.openxmlformats.org/presentationml/2006/main">
   <p:cSld>
     <p:bg>
       <p:bgPr>
-        <a:solidFill xmlns:a="http://schemas.openxmlformats.org/drawingml/2006/main">
+        <a:solidFill>
           <a:srgbClr val="F5F6F1"/>
         </a:solidFill>
       </p:bgPr>
@@ -20579,40 +20579,40 @@
         <p:nvPr/>
       </p:nvGrpSpPr>
       <p:grpSpPr>
-        <a:xfrm xmlns:a="http://schemas.openxmlformats.org/drawingml/2006/main"/>
+        <a:xfrm/>
       </p:grpSpPr>
       <p:sp>
         <p:nvSpPr>
           <p:cNvPr id="2" name="Complete action chains">
-            <a:extLst xmlns:a="http://schemas.openxmlformats.org/drawingml/2006/main">
+            <a:extLst>
               <a:ext uri="{FF2B5EF4-FFF2-40B4-BE49-F238E27FC236}">
-                <a16:creationId xmlns:a16="http://schemas.microsoft.com/office/drawing/2014/main" id="{2B7B4AEC-57E9-4D4B-84AD-307ECDF327AA}"/>
+                <ns2:creationId id="{2B7B4AEC-57E9-4D4B-84AD-307ECDF327AA}"/>
               </a:ext>
             </a:extLst>
           </p:cNvPr>
           <p:cNvSpPr>
-            <a:spLocks xmlns:a="http://schemas.openxmlformats.org/drawingml/2006/main" noGrp="1"/>
+            <a:spLocks noGrp="1"/>
           </p:cNvSpPr>
           <p:nvPr/>
         </p:nvSpPr>
         <p:spPr>
-          <a:xfrm xmlns:a="http://schemas.openxmlformats.org/drawingml/2006/main">
+          <a:xfrm>
             <a:off x="609600" y="457200"/>
             <a:ext cx="10972800" cy="647700"/>
           </a:xfrm>
-          <a:prstGeom xmlns:a="http://schemas.openxmlformats.org/drawingml/2006/main" prst="rect">
+          <a:prstGeom prst="rect">
             <a:avLst/>
           </a:prstGeom>
-          <a:noFill xmlns:a="http://schemas.openxmlformats.org/drawingml/2006/main"/>
-          <a:ln xmlns:a="http://schemas.openxmlformats.org/drawingml/2006/main" w="0">
+          <a:noFill/>
+          <a:ln w="0">
             <a:noFill/>
           </a:ln>
         </p:spPr>
         <p:txBody>
-          <a:bodyPr xmlns:a="http://schemas.openxmlformats.org/drawingml/2006/main" wrap="square" lIns="0" tIns="0" rIns="0" bIns="0" anchor="t">
+          <a:bodyPr wrap="square" lIns="0" tIns="0" rIns="0" bIns="0" anchor="t">
             <a:noAutofit/>
           </a:bodyPr>
-          <a:lstStyle xmlns:a="http://schemas.openxmlformats.org/drawingml/2006/main">
+          <a:lstStyle>
             <a:defPPr algn="l">
               <a:defRPr sz="3300" b="1">
                 <a:solidFill>
@@ -20714,7 +20714,7 @@
               </a:defRPr>
             </a:lvl9pPr>
           </a:lstStyle>
-          <a:p xmlns:a="http://schemas.openxmlformats.org/drawingml/2006/main">
+          <a:p>
             <a:pPr algn="l">
               <a:defRPr sz="3300" b="1">
                 <a:solidFill>
@@ -20742,35 +20742,35 @@
       <p:sp>
         <p:nvSpPr>
           <p:cNvPr id="3" name="Exact matches across the 10 complete videos">
-            <a:extLst xmlns:a="http://schemas.openxmlformats.org/drawingml/2006/main">
+            <a:extLst>
               <a:ext uri="{FF2B5EF4-FFF2-40B4-BE49-F238E27FC236}">
-                <a16:creationId xmlns:a16="http://schemas.microsoft.com/office/drawing/2014/main" id="{DF7A61DA-4B92-4096-BD99-6F316AC7A75D}"/>
+                <ns2:creationId id="{DF7A61DA-4B92-4096-BD99-6F316AC7A75D}"/>
               </a:ext>
             </a:extLst>
           </p:cNvPr>
           <p:cNvSpPr>
-            <a:spLocks xmlns:a="http://schemas.openxmlformats.org/drawingml/2006/main" noGrp="1"/>
+            <a:spLocks noGrp="1"/>
           </p:cNvSpPr>
           <p:nvPr/>
         </p:nvSpPr>
         <p:spPr>
-          <a:xfrm xmlns:a="http://schemas.openxmlformats.org/drawingml/2006/main">
+          <a:xfrm>
             <a:off x="609600" y="1152525"/>
             <a:ext cx="10972800" cy="438150"/>
           </a:xfrm>
-          <a:prstGeom xmlns:a="http://schemas.openxmlformats.org/drawingml/2006/main" prst="rect">
+          <a:prstGeom prst="rect">
             <a:avLst/>
           </a:prstGeom>
-          <a:noFill xmlns:a="http://schemas.openxmlformats.org/drawingml/2006/main"/>
-          <a:ln xmlns:a="http://schemas.openxmlformats.org/drawingml/2006/main" w="0">
+          <a:noFill/>
+          <a:ln w="0">
             <a:noFill/>
           </a:ln>
         </p:spPr>
         <p:txBody>
-          <a:bodyPr xmlns:a="http://schemas.openxmlformats.org/drawingml/2006/main" wrap="square" lIns="0" tIns="0" rIns="0" bIns="0" anchor="t">
+          <a:bodyPr wrap="square" lIns="0" tIns="0" rIns="0" bIns="0" anchor="t">
             <a:noAutofit/>
           </a:bodyPr>
-          <a:lstStyle xmlns:a="http://schemas.openxmlformats.org/drawingml/2006/main">
+          <a:lstStyle>
             <a:defPPr algn="l">
               <a:defRPr sz="1800" b="0">
                 <a:solidFill>
@@ -20872,7 +20872,7 @@
               </a:defRPr>
             </a:lvl9pPr>
           </a:lstStyle>
-          <a:p xmlns:a="http://schemas.openxmlformats.org/drawingml/2006/main">
+          <a:p>
             <a:pPr algn="l">
               <a:defRPr sz="1800" b="0">
                 <a:solidFill>
@@ -20900,35 +20900,35 @@
       <p:sp>
         <p:nvSpPr>
           <p:cNvPr id="4" name="GROUP 43  /  FINAL PROJECT">
-            <a:extLst xmlns:a="http://schemas.openxmlformats.org/drawingml/2006/main">
+            <a:extLst>
               <a:ext uri="{FF2B5EF4-FFF2-40B4-BE49-F238E27FC236}">
-                <a16:creationId xmlns:a16="http://schemas.microsoft.com/office/drawing/2014/main" id="{8071392B-8A89-402F-8F69-A298352A2AFF}"/>
+                <ns2:creationId id="{8071392B-8A89-402F-8F69-A298352A2AFF}"/>
               </a:ext>
             </a:extLst>
           </p:cNvPr>
           <p:cNvSpPr>
-            <a:spLocks xmlns:a="http://schemas.openxmlformats.org/drawingml/2006/main" noGrp="1"/>
+            <a:spLocks noGrp="1"/>
           </p:cNvSpPr>
           <p:nvPr/>
         </p:nvSpPr>
         <p:spPr>
-          <a:xfrm xmlns:a="http://schemas.openxmlformats.org/drawingml/2006/main">
+          <a:xfrm>
             <a:off x="609600" y="6400800"/>
             <a:ext cx="6667500" cy="228600"/>
           </a:xfrm>
-          <a:prstGeom xmlns:a="http://schemas.openxmlformats.org/drawingml/2006/main" prst="rect">
+          <a:prstGeom prst="rect">
             <a:avLst/>
           </a:prstGeom>
-          <a:noFill xmlns:a="http://schemas.openxmlformats.org/drawingml/2006/main"/>
-          <a:ln xmlns:a="http://schemas.openxmlformats.org/drawingml/2006/main" w="0">
+          <a:noFill/>
+          <a:ln w="0">
             <a:noFill/>
           </a:ln>
         </p:spPr>
         <p:txBody>
-          <a:bodyPr xmlns:a="http://schemas.openxmlformats.org/drawingml/2006/main" wrap="square" lIns="0" tIns="0" rIns="0" bIns="0" anchor="t">
+          <a:bodyPr wrap="square" lIns="0" tIns="0" rIns="0" bIns="0" anchor="t">
             <a:noAutofit/>
           </a:bodyPr>
-          <a:lstStyle xmlns:a="http://schemas.openxmlformats.org/drawingml/2006/main">
+          <a:lstStyle>
             <a:defPPr algn="l">
               <a:defRPr sz="1200" b="0">
                 <a:solidFill>
@@ -21030,7 +21030,7 @@
               </a:defRPr>
             </a:lvl9pPr>
           </a:lstStyle>
-          <a:p xmlns:a="http://schemas.openxmlformats.org/drawingml/2006/main">
+          <a:p>
             <a:pPr algn="l">
               <a:defRPr sz="1200" b="0">
                 <a:solidFill>
@@ -21058,35 +21058,35 @@
       <p:sp>
         <p:nvSpPr>
           <p:cNvPr id="5" name="09">
-            <a:extLst xmlns:a="http://schemas.openxmlformats.org/drawingml/2006/main">
+            <a:extLst>
               <a:ext uri="{FF2B5EF4-FFF2-40B4-BE49-F238E27FC236}">
-                <a16:creationId xmlns:a16="http://schemas.microsoft.com/office/drawing/2014/main" id="{18A6763A-A287-45F0-B833-3DAA02FB94F1}"/>
+                <ns2:creationId id="{18A6763A-A287-45F0-B833-3DAA02FB94F1}"/>
               </a:ext>
             </a:extLst>
           </p:cNvPr>
           <p:cNvSpPr>
-            <a:spLocks xmlns:a="http://schemas.openxmlformats.org/drawingml/2006/main" noGrp="1"/>
+            <a:spLocks noGrp="1"/>
           </p:cNvSpPr>
           <p:nvPr/>
         </p:nvSpPr>
         <p:spPr>
-          <a:xfrm xmlns:a="http://schemas.openxmlformats.org/drawingml/2006/main">
+          <a:xfrm>
             <a:off x="11049000" y="6372225"/>
             <a:ext cx="533400" cy="285750"/>
           </a:xfrm>
-          <a:prstGeom xmlns:a="http://schemas.openxmlformats.org/drawingml/2006/main" prst="rect">
+          <a:prstGeom prst="rect">
             <a:avLst/>
           </a:prstGeom>
-          <a:noFill xmlns:a="http://schemas.openxmlformats.org/drawingml/2006/main"/>
-          <a:ln xmlns:a="http://schemas.openxmlformats.org/drawingml/2006/main" w="0">
+          <a:noFill/>
+          <a:ln w="0">
             <a:noFill/>
           </a:ln>
         </p:spPr>
         <p:txBody>
-          <a:bodyPr xmlns:a="http://schemas.openxmlformats.org/drawingml/2006/main" wrap="square" lIns="0" tIns="0" rIns="0" bIns="0" anchor="t">
+          <a:bodyPr wrap="square" lIns="0" tIns="0" rIns="0" bIns="0" anchor="t">
             <a:noAutofit/>
           </a:bodyPr>
-          <a:lstStyle xmlns:a="http://schemas.openxmlformats.org/drawingml/2006/main">
+          <a:lstStyle>
             <a:defPPr algn="r">
               <a:defRPr sz="1500" b="0">
                 <a:solidFill>
@@ -21188,7 +21188,7 @@
               </a:defRPr>
             </a:lvl9pPr>
           </a:lstStyle>
-          <a:p xmlns:a="http://schemas.openxmlformats.org/drawingml/2006/main">
+          <a:p>
             <a:pPr algn="r">
               <a:defRPr sz="1500" b="0">
                 <a:solidFill>
@@ -21216,9 +21216,9 @@
       <p:graphicFrame>
         <p:nvGraphicFramePr>
           <p:cNvPr id="6" name="Chart">
-            <a:extLst xmlns:a="http://schemas.openxmlformats.org/drawingml/2006/main">
+            <a:extLst>
               <a:ext uri="{FF2B5EF4-FFF2-40B4-BE49-F238E27FC236}">
-                <a16:creationId xmlns:a16="http://schemas.microsoft.com/office/drawing/2014/main" id="{F9B0CB53-59EC-4B66-A66F-3D1A09270136}"/>
+                <ns2:creationId id="{F9B0CB53-59EC-4B66-A66F-3D1A09270136}"/>
               </a:ext>
             </a:extLst>
           </p:cNvPr>
@@ -21226,47 +21226,47 @@
           <p:nvPr/>
         </p:nvGraphicFramePr>
         <p:xfrm>
-          <a:off xmlns:a="http://schemas.openxmlformats.org/drawingml/2006/main" x="609600" y="1924050"/>
-          <a:ext xmlns:a="http://schemas.openxmlformats.org/drawingml/2006/main" cx="7191375" cy="3619500"/>
+          <a:off x="609600" y="1924050"/>
+          <a:ext cx="7191375" cy="3619500"/>
         </p:xfrm>
-        <a:graphic xmlns:a="http://schemas.openxmlformats.org/drawingml/2006/main">
+        <a:graphic>
           <a:graphicData uri="http://schemas.openxmlformats.org/drawingml/2006/chart">
-            <c:chart xmlns:r="http://schemas.openxmlformats.org/officeDocument/2006/relationships" xmlns:c="http://schemas.openxmlformats.org/drawingml/2006/chart" r:id="Rb6428ae19a5947cf"/>
+            <c:chart ns4:id="Rb6428ae19a5947cf"/>
           </a:graphicData>
         </a:graphic>
       </p:graphicFrame>
       <p:sp>
         <p:nvSpPr>
           <p:cNvPr id="7" name="Observed errors preserved">
-            <a:extLst xmlns:a="http://schemas.openxmlformats.org/drawingml/2006/main">
+            <a:extLst>
               <a:ext uri="{FF2B5EF4-FFF2-40B4-BE49-F238E27FC236}">
-                <a16:creationId xmlns:a16="http://schemas.microsoft.com/office/drawing/2014/main" id="{CAD558F6-DCDE-4C32-8300-CA02C3393B56}"/>
+                <ns2:creationId id="{CAD558F6-DCDE-4C32-8300-CA02C3393B56}"/>
               </a:ext>
             </a:extLst>
           </p:cNvPr>
           <p:cNvSpPr>
-            <a:spLocks xmlns:a="http://schemas.openxmlformats.org/drawingml/2006/main" noGrp="1"/>
+            <a:spLocks noGrp="1"/>
           </p:cNvSpPr>
           <p:nvPr/>
         </p:nvSpPr>
         <p:spPr>
-          <a:xfrm xmlns:a="http://schemas.openxmlformats.org/drawingml/2006/main">
+          <a:xfrm>
             <a:off x="8220075" y="1952625"/>
             <a:ext cx="3333750" cy="809625"/>
           </a:xfrm>
-          <a:prstGeom xmlns:a="http://schemas.openxmlformats.org/drawingml/2006/main" prst="rect">
+          <a:prstGeom prst="rect">
             <a:avLst/>
           </a:prstGeom>
-          <a:noFill xmlns:a="http://schemas.openxmlformats.org/drawingml/2006/main"/>
-          <a:ln xmlns:a="http://schemas.openxmlformats.org/drawingml/2006/main" w="0">
+          <a:noFill/>
+          <a:ln w="0">
             <a:noFill/>
           </a:ln>
         </p:spPr>
         <p:txBody>
-          <a:bodyPr xmlns:a="http://schemas.openxmlformats.org/drawingml/2006/main" wrap="square" lIns="0" tIns="0" rIns="0" bIns="0" anchor="t">
+          <a:bodyPr wrap="square" lIns="0" tIns="0" rIns="0" bIns="0" anchor="t">
             <a:noAutofit/>
           </a:bodyPr>
-          <a:lstStyle xmlns:a="http://schemas.openxmlformats.org/drawingml/2006/main">
+          <a:lstStyle>
             <a:defPPr algn="l">
               <a:defRPr sz="2175" b="1">
                 <a:solidFill>
@@ -21368,7 +21368,7 @@
               </a:defRPr>
             </a:lvl9pPr>
           </a:lstStyle>
-          <a:p xmlns:a="http://schemas.openxmlformats.org/drawingml/2006/main">
+          <a:p>
             <a:pPr algn="l">
               <a:defRPr sz="2175" b="1">
                 <a:solidFill>
@@ -21396,35 +21396,35 @@
       <p:sp>
         <p:nvSpPr>
           <p:cNvPr id="8" name="Missing Step 4">
-            <a:extLst xmlns:a="http://schemas.openxmlformats.org/drawingml/2006/main">
+            <a:extLst>
               <a:ext uri="{FF2B5EF4-FFF2-40B4-BE49-F238E27FC236}">
-                <a16:creationId xmlns:a16="http://schemas.microsoft.com/office/drawing/2014/main" id="{5BE5F85B-075C-4BA0-810C-463759344F5A}"/>
+                <ns2:creationId id="{5BE5F85B-075C-4BA0-810C-463759344F5A}"/>
               </a:ext>
             </a:extLst>
           </p:cNvPr>
           <p:cNvSpPr>
-            <a:spLocks xmlns:a="http://schemas.openxmlformats.org/drawingml/2006/main" noGrp="1"/>
+            <a:spLocks noGrp="1"/>
           </p:cNvSpPr>
           <p:nvPr/>
         </p:nvSpPr>
         <p:spPr>
-          <a:xfrm xmlns:a="http://schemas.openxmlformats.org/drawingml/2006/main">
+          <a:xfrm>
             <a:off x="8220075" y="3181350"/>
             <a:ext cx="3333750" cy="381000"/>
           </a:xfrm>
-          <a:prstGeom xmlns:a="http://schemas.openxmlformats.org/drawingml/2006/main" prst="rect">
+          <a:prstGeom prst="rect">
             <a:avLst/>
           </a:prstGeom>
-          <a:noFill xmlns:a="http://schemas.openxmlformats.org/drawingml/2006/main"/>
-          <a:ln xmlns:a="http://schemas.openxmlformats.org/drawingml/2006/main" w="0">
+          <a:noFill/>
+          <a:ln w="0">
             <a:noFill/>
           </a:ln>
         </p:spPr>
         <p:txBody>
-          <a:bodyPr xmlns:a="http://schemas.openxmlformats.org/drawingml/2006/main" wrap="square" lIns="0" tIns="0" rIns="0" bIns="0" anchor="t">
+          <a:bodyPr wrap="square" lIns="0" tIns="0" rIns="0" bIns="0" anchor="t">
             <a:noAutofit/>
           </a:bodyPr>
-          <a:lstStyle xmlns:a="http://schemas.openxmlformats.org/drawingml/2006/main">
+          <a:lstStyle>
             <a:defPPr algn="l">
               <a:defRPr sz="1800" b="0">
                 <a:solidFill>
@@ -21526,7 +21526,7 @@
               </a:defRPr>
             </a:lvl9pPr>
           </a:lstStyle>
-          <a:p xmlns:a="http://schemas.openxmlformats.org/drawingml/2006/main">
+          <a:p>
             <a:pPr algn="l">
               <a:defRPr sz="1800" b="0">
                 <a:solidFill>
@@ -21554,35 +21554,35 @@
       <p:sp>
         <p:nvSpPr>
           <p:cNvPr id="9" name="1  2  3  5  6">
-            <a:extLst xmlns:a="http://schemas.openxmlformats.org/drawingml/2006/main">
+            <a:extLst>
               <a:ext uri="{FF2B5EF4-FFF2-40B4-BE49-F238E27FC236}">
-                <a16:creationId xmlns:a16="http://schemas.microsoft.com/office/drawing/2014/main" id="{C275AC42-9864-451C-9574-2D7E74F2DA65}"/>
+                <ns2:creationId id="{C275AC42-9864-451C-9574-2D7E74F2DA65}"/>
               </a:ext>
             </a:extLst>
           </p:cNvPr>
           <p:cNvSpPr>
-            <a:spLocks xmlns:a="http://schemas.openxmlformats.org/drawingml/2006/main" noGrp="1"/>
+            <a:spLocks noGrp="1"/>
           </p:cNvSpPr>
           <p:nvPr/>
         </p:nvSpPr>
         <p:spPr>
-          <a:xfrm xmlns:a="http://schemas.openxmlformats.org/drawingml/2006/main">
+          <a:xfrm>
             <a:off x="8220075" y="3648075"/>
             <a:ext cx="3333750" cy="523875"/>
           </a:xfrm>
-          <a:prstGeom xmlns:a="http://schemas.openxmlformats.org/drawingml/2006/main" prst="rect">
+          <a:prstGeom prst="rect">
             <a:avLst/>
           </a:prstGeom>
-          <a:noFill xmlns:a="http://schemas.openxmlformats.org/drawingml/2006/main"/>
-          <a:ln xmlns:a="http://schemas.openxmlformats.org/drawingml/2006/main" w="0">
+          <a:noFill/>
+          <a:ln w="0">
             <a:noFill/>
           </a:ln>
         </p:spPr>
         <p:txBody>
-          <a:bodyPr xmlns:a="http://schemas.openxmlformats.org/drawingml/2006/main" wrap="square" lIns="0" tIns="0" rIns="0" bIns="0" anchor="t">
+          <a:bodyPr wrap="square" lIns="0" tIns="0" rIns="0" bIns="0" anchor="t">
             <a:noAutofit/>
           </a:bodyPr>
-          <a:lstStyle xmlns:a="http://schemas.openxmlformats.org/drawingml/2006/main">
+          <a:lstStyle>
             <a:defPPr algn="l">
               <a:defRPr sz="2475" b="1">
                 <a:solidFill>
@@ -21684,7 +21684,7 @@
               </a:defRPr>
             </a:lvl9pPr>
           </a:lstStyle>
-          <a:p xmlns:a="http://schemas.openxmlformats.org/drawingml/2006/main">
+          <a:p>
             <a:pPr algn="l">
               <a:defRPr sz="2475" b="1">
                 <a:solidFill>
@@ -21712,35 +21712,35 @@
       <p:sp>
         <p:nvSpPr>
           <p:cNvPr id="10" name="Reordered sequence">
-            <a:extLst xmlns:a="http://schemas.openxmlformats.org/drawingml/2006/main">
+            <a:extLst>
               <a:ext uri="{FF2B5EF4-FFF2-40B4-BE49-F238E27FC236}">
-                <a16:creationId xmlns:a16="http://schemas.microsoft.com/office/drawing/2014/main" id="{6DCFCFDC-E99E-4298-831B-D22DF1D6810E}"/>
+                <ns2:creationId id="{6DCFCFDC-E99E-4298-831B-D22DF1D6810E}"/>
               </a:ext>
             </a:extLst>
           </p:cNvPr>
           <p:cNvSpPr>
-            <a:spLocks xmlns:a="http://schemas.openxmlformats.org/drawingml/2006/main" noGrp="1"/>
+            <a:spLocks noGrp="1"/>
           </p:cNvSpPr>
           <p:nvPr/>
         </p:nvSpPr>
         <p:spPr>
-          <a:xfrm xmlns:a="http://schemas.openxmlformats.org/drawingml/2006/main">
+          <a:xfrm>
             <a:off x="8220075" y="4476750"/>
             <a:ext cx="3333750" cy="381000"/>
           </a:xfrm>
-          <a:prstGeom xmlns:a="http://schemas.openxmlformats.org/drawingml/2006/main" prst="rect">
+          <a:prstGeom prst="rect">
             <a:avLst/>
           </a:prstGeom>
-          <a:noFill xmlns:a="http://schemas.openxmlformats.org/drawingml/2006/main"/>
-          <a:ln xmlns:a="http://schemas.openxmlformats.org/drawingml/2006/main" w="0">
+          <a:noFill/>
+          <a:ln w="0">
             <a:noFill/>
           </a:ln>
         </p:spPr>
         <p:txBody>
-          <a:bodyPr xmlns:a="http://schemas.openxmlformats.org/drawingml/2006/main" wrap="square" lIns="0" tIns="0" rIns="0" bIns="0" anchor="t">
+          <a:bodyPr wrap="square" lIns="0" tIns="0" rIns="0" bIns="0" anchor="t">
             <a:noAutofit/>
           </a:bodyPr>
-          <a:lstStyle xmlns:a="http://schemas.openxmlformats.org/drawingml/2006/main">
+          <a:lstStyle>
             <a:defPPr algn="l">
               <a:defRPr sz="1800" b="0">
                 <a:solidFill>
@@ -21842,7 +21842,7 @@
               </a:defRPr>
             </a:lvl9pPr>
           </a:lstStyle>
-          <a:p xmlns:a="http://schemas.openxmlformats.org/drawingml/2006/main">
+          <a:p>
             <a:pPr algn="l">
               <a:defRPr sz="1800" b="0">
                 <a:solidFill>
@@ -21870,35 +21870,35 @@
       <p:sp>
         <p:nvSpPr>
           <p:cNvPr id="11" name="6  4  5  3  2  1">
-            <a:extLst xmlns:a="http://schemas.openxmlformats.org/drawingml/2006/main">
+            <a:extLst>
               <a:ext uri="{FF2B5EF4-FFF2-40B4-BE49-F238E27FC236}">
-                <a16:creationId xmlns:a16="http://schemas.microsoft.com/office/drawing/2014/main" id="{AB139615-7E62-418F-8000-B28EBE6F5E45}"/>
+                <ns2:creationId id="{AB139615-7E62-418F-8000-B28EBE6F5E45}"/>
               </a:ext>
             </a:extLst>
           </p:cNvPr>
           <p:cNvSpPr>
-            <a:spLocks xmlns:a="http://schemas.openxmlformats.org/drawingml/2006/main" noGrp="1"/>
+            <a:spLocks noGrp="1"/>
           </p:cNvSpPr>
           <p:nvPr/>
         </p:nvSpPr>
         <p:spPr>
-          <a:xfrm xmlns:a="http://schemas.openxmlformats.org/drawingml/2006/main">
+          <a:xfrm>
             <a:off x="8220075" y="4943475"/>
             <a:ext cx="3333750" cy="523875"/>
           </a:xfrm>
-          <a:prstGeom xmlns:a="http://schemas.openxmlformats.org/drawingml/2006/main" prst="rect">
+          <a:prstGeom prst="rect">
             <a:avLst/>
           </a:prstGeom>
-          <a:noFill xmlns:a="http://schemas.openxmlformats.org/drawingml/2006/main"/>
-          <a:ln xmlns:a="http://schemas.openxmlformats.org/drawingml/2006/main" w="0">
+          <a:noFill/>
+          <a:ln w="0">
             <a:noFill/>
           </a:ln>
         </p:spPr>
         <p:txBody>
-          <a:bodyPr xmlns:a="http://schemas.openxmlformats.org/drawingml/2006/main" wrap="square" lIns="0" tIns="0" rIns="0" bIns="0" anchor="t">
+          <a:bodyPr wrap="square" lIns="0" tIns="0" rIns="0" bIns="0" anchor="t">
             <a:noAutofit/>
           </a:bodyPr>
-          <a:lstStyle xmlns:a="http://schemas.openxmlformats.org/drawingml/2006/main">
+          <a:lstStyle>
             <a:defPPr algn="l">
               <a:defRPr sz="2475" b="1">
                 <a:solidFill>
@@ -22000,7 +22000,7 @@
               </a:defRPr>
             </a:lvl9pPr>
           </a:lstStyle>
-          <a:p xmlns:a="http://schemas.openxmlformats.org/drawingml/2006/main">
+          <a:p>
             <a:pPr algn="l">
               <a:defRPr sz="2475" b="1">
                 <a:solidFill>
@@ -22028,35 +22028,35 @@
       <p:sp>
         <p:nvSpPr>
           <p:cNvPr id="12" name="Only the proposed method applies adaptive confirmation to de">
-            <a:extLst xmlns:a="http://schemas.openxmlformats.org/drawingml/2006/main">
+            <a:extLst>
               <a:ext uri="{FF2B5EF4-FFF2-40B4-BE49-F238E27FC236}">
-                <a16:creationId xmlns:a16="http://schemas.microsoft.com/office/drawing/2014/main" id="{49F73F84-9ABF-42C7-9CD5-99B3F1BC16F7}"/>
+                <ns2:creationId id="{49F73F84-9ABF-42C7-9CD5-99B3F1BC16F7}"/>
               </a:ext>
             </a:extLst>
           </p:cNvPr>
           <p:cNvSpPr>
-            <a:spLocks xmlns:a="http://schemas.openxmlformats.org/drawingml/2006/main" noGrp="1"/>
+            <a:spLocks noGrp="1"/>
           </p:cNvSpPr>
           <p:nvPr/>
         </p:nvSpPr>
         <p:spPr>
-          <a:xfrm xmlns:a="http://schemas.openxmlformats.org/drawingml/2006/main">
+          <a:xfrm>
             <a:off x="609600" y="5857875"/>
             <a:ext cx="10972800" cy="361950"/>
           </a:xfrm>
-          <a:prstGeom xmlns:a="http://schemas.openxmlformats.org/drawingml/2006/main" prst="rect">
+          <a:prstGeom prst="rect">
             <a:avLst/>
           </a:prstGeom>
-          <a:noFill xmlns:a="http://schemas.openxmlformats.org/drawingml/2006/main"/>
-          <a:ln xmlns:a="http://schemas.openxmlformats.org/drawingml/2006/main" w="0">
+          <a:noFill/>
+          <a:ln w="0">
             <a:noFill/>
           </a:ln>
         </p:spPr>
         <p:txBody>
-          <a:bodyPr xmlns:a="http://schemas.openxmlformats.org/drawingml/2006/main" wrap="square" lIns="0" tIns="0" rIns="0" bIns="0" anchor="t">
+          <a:bodyPr wrap="square" lIns="0" tIns="0" rIns="0" bIns="0" anchor="t">
             <a:noAutofit/>
           </a:bodyPr>
-          <a:lstStyle xmlns:a="http://schemas.openxmlformats.org/drawingml/2006/main">
+          <a:lstStyle>
             <a:defPPr algn="l">
               <a:defRPr sz="1500" b="0">
                 <a:solidFill>
@@ -22158,7 +22158,7 @@
               </a:defRPr>
             </a:lvl9pPr>
           </a:lstStyle>
-          <a:p xmlns:a="http://schemas.openxmlformats.org/drawingml/2006/main">
+          <a:p>
             <a:pPr algn="l">
               <a:defRPr sz="1500" b="0">
                 <a:solidFill>
@@ -22179,6 +22179,614 @@
                 <a:cs typeface="Arial"/>
               </a:rPr>
               <a:t>Only the proposed method applies adaptive confirmation to dense 5 fps predictions.</a:t>
+            </a:r>
+          </a:p>
+        </p:txBody>
+      </p:sp>
+      <p:sp>
+        <p:nvSpPr>
+          <p:cNvPr id="13" name="Chart value 2"/>
+          <p:cNvSpPr>
+            <a:spLocks noGrp="1"/>
+          </p:cNvSpPr>
+          <p:nvPr/>
+        </p:nvSpPr>
+        <p:spPr>
+          <a:xfrm>
+            <a:off x="1647825" y="4305300"/>
+            <a:ext cx="400050" cy="342900"/>
+          </a:xfrm>
+          <a:prstGeom prst="rect">
+            <a:avLst/>
+          </a:prstGeom>
+          <a:noFill/>
+          <a:ln w="0">
+            <a:noFill/>
+          </a:ln>
+        </p:spPr>
+        <p:txBody>
+          <a:bodyPr wrap="square" lIns="0" tIns="0" rIns="0" bIns="0" anchor="ctr">
+            <a:noAutofit/>
+          </a:bodyPr>
+          <a:lstStyle>
+            <a:defPPr algn="l">
+              <a:defRPr sz="1950" b="1">
+                <a:solidFill>
+                  <a:srgbClr val="1D3B33"/>
+                </a:solidFill>
+                <a:latin typeface="Arial"/>
+                <a:ea typeface="Arial"/>
+                <a:cs typeface="Arial"/>
+              </a:defRPr>
+            </a:defPPr>
+            <a:lvl1pPr algn="l">
+              <a:defRPr sz="1950" b="1">
+                <a:solidFill>
+                  <a:srgbClr val="1D3B33"/>
+                </a:solidFill>
+                <a:latin typeface="Arial"/>
+                <a:ea typeface="Arial"/>
+                <a:cs typeface="Arial"/>
+              </a:defRPr>
+            </a:lvl1pPr>
+            <a:lvl2pPr algn="l">
+              <a:defRPr sz="1950" b="1">
+                <a:solidFill>
+                  <a:srgbClr val="1D3B33"/>
+                </a:solidFill>
+                <a:latin typeface="Arial"/>
+                <a:ea typeface="Arial"/>
+                <a:cs typeface="Arial"/>
+              </a:defRPr>
+            </a:lvl2pPr>
+            <a:lvl3pPr algn="l">
+              <a:defRPr sz="1950" b="1">
+                <a:solidFill>
+                  <a:srgbClr val="1D3B33"/>
+                </a:solidFill>
+                <a:latin typeface="Arial"/>
+                <a:ea typeface="Arial"/>
+                <a:cs typeface="Arial"/>
+              </a:defRPr>
+            </a:lvl3pPr>
+            <a:lvl4pPr algn="l">
+              <a:defRPr sz="1950" b="1">
+                <a:solidFill>
+                  <a:srgbClr val="1D3B33"/>
+                </a:solidFill>
+                <a:latin typeface="Arial"/>
+                <a:ea typeface="Arial"/>
+                <a:cs typeface="Arial"/>
+              </a:defRPr>
+            </a:lvl4pPr>
+            <a:lvl5pPr algn="l">
+              <a:defRPr sz="1950" b="1">
+                <a:solidFill>
+                  <a:srgbClr val="1D3B33"/>
+                </a:solidFill>
+                <a:latin typeface="Arial"/>
+                <a:ea typeface="Arial"/>
+                <a:cs typeface="Arial"/>
+              </a:defRPr>
+            </a:lvl5pPr>
+            <a:lvl6pPr algn="l">
+              <a:defRPr sz="1950" b="1">
+                <a:solidFill>
+                  <a:srgbClr val="1D3B33"/>
+                </a:solidFill>
+                <a:latin typeface="Arial"/>
+                <a:ea typeface="Arial"/>
+                <a:cs typeface="Arial"/>
+              </a:defRPr>
+            </a:lvl6pPr>
+            <a:lvl7pPr algn="l">
+              <a:defRPr sz="1950" b="1">
+                <a:solidFill>
+                  <a:srgbClr val="1D3B33"/>
+                </a:solidFill>
+                <a:latin typeface="Arial"/>
+                <a:ea typeface="Arial"/>
+                <a:cs typeface="Arial"/>
+              </a:defRPr>
+            </a:lvl7pPr>
+            <a:lvl8pPr algn="l">
+              <a:defRPr sz="1950" b="1">
+                <a:solidFill>
+                  <a:srgbClr val="1D3B33"/>
+                </a:solidFill>
+                <a:latin typeface="Arial"/>
+                <a:ea typeface="Arial"/>
+                <a:cs typeface="Arial"/>
+              </a:defRPr>
+            </a:lvl8pPr>
+            <a:lvl9pPr algn="l">
+              <a:defRPr sz="1950" b="1">
+                <a:solidFill>
+                  <a:srgbClr val="1D3B33"/>
+                </a:solidFill>
+                <a:latin typeface="Arial"/>
+                <a:ea typeface="Arial"/>
+                <a:cs typeface="Arial"/>
+              </a:defRPr>
+            </a:lvl9pPr>
+          </a:lstStyle>
+          <a:p>
+            <a:pPr algn="ctr">
+              <a:defRPr sz="1950" b="1">
+                <a:solidFill>
+                  <a:srgbClr val="1D3B33"/>
+                </a:solidFill>
+                <a:latin typeface="Arial"/>
+                <a:ea typeface="Arial"/>
+                <a:cs typeface="Arial"/>
+              </a:defRPr>
+            </a:pPr>
+            <a:r>
+              <a:rPr sz="1950" b="1">
+                <a:solidFill>
+                  <a:srgbClr val="1D3B33"/>
+                </a:solidFill>
+                <a:latin typeface="Arial"/>
+                <a:ea typeface="Arial"/>
+                <a:cs typeface="Arial"/>
+              </a:rPr>
+              <a:t>2</a:t>
+            </a:r>
+          </a:p>
+        </p:txBody>
+      </p:sp>
+      <p:sp>
+        <p:nvSpPr>
+          <p:cNvPr id="14" name="Chart value 6"/>
+          <p:cNvSpPr>
+            <a:spLocks noGrp="1"/>
+          </p:cNvSpPr>
+          <p:nvPr/>
+        </p:nvSpPr>
+        <p:spPr>
+          <a:xfrm>
+            <a:off x="3305175" y="2981325"/>
+            <a:ext cx="400050" cy="342900"/>
+          </a:xfrm>
+          <a:prstGeom prst="rect">
+            <a:avLst/>
+          </a:prstGeom>
+          <a:noFill/>
+          <a:ln w="0">
+            <a:noFill/>
+          </a:ln>
+        </p:spPr>
+        <p:txBody>
+          <a:bodyPr wrap="square" lIns="0" tIns="0" rIns="0" bIns="0" anchor="ctr">
+            <a:noAutofit/>
+          </a:bodyPr>
+          <a:lstStyle>
+            <a:defPPr algn="l">
+              <a:defRPr sz="1950" b="1">
+                <a:solidFill>
+                  <a:srgbClr val="1D3B33"/>
+                </a:solidFill>
+                <a:latin typeface="Arial"/>
+                <a:ea typeface="Arial"/>
+                <a:cs typeface="Arial"/>
+              </a:defRPr>
+            </a:defPPr>
+            <a:lvl1pPr algn="l">
+              <a:defRPr sz="1950" b="1">
+                <a:solidFill>
+                  <a:srgbClr val="1D3B33"/>
+                </a:solidFill>
+                <a:latin typeface="Arial"/>
+                <a:ea typeface="Arial"/>
+                <a:cs typeface="Arial"/>
+              </a:defRPr>
+            </a:lvl1pPr>
+            <a:lvl2pPr algn="l">
+              <a:defRPr sz="1950" b="1">
+                <a:solidFill>
+                  <a:srgbClr val="1D3B33"/>
+                </a:solidFill>
+                <a:latin typeface="Arial"/>
+                <a:ea typeface="Arial"/>
+                <a:cs typeface="Arial"/>
+              </a:defRPr>
+            </a:lvl2pPr>
+            <a:lvl3pPr algn="l">
+              <a:defRPr sz="1950" b="1">
+                <a:solidFill>
+                  <a:srgbClr val="1D3B33"/>
+                </a:solidFill>
+                <a:latin typeface="Arial"/>
+                <a:ea typeface="Arial"/>
+                <a:cs typeface="Arial"/>
+              </a:defRPr>
+            </a:lvl3pPr>
+            <a:lvl4pPr algn="l">
+              <a:defRPr sz="1950" b="1">
+                <a:solidFill>
+                  <a:srgbClr val="1D3B33"/>
+                </a:solidFill>
+                <a:latin typeface="Arial"/>
+                <a:ea typeface="Arial"/>
+                <a:cs typeface="Arial"/>
+              </a:defRPr>
+            </a:lvl4pPr>
+            <a:lvl5pPr algn="l">
+              <a:defRPr sz="1950" b="1">
+                <a:solidFill>
+                  <a:srgbClr val="1D3B33"/>
+                </a:solidFill>
+                <a:latin typeface="Arial"/>
+                <a:ea typeface="Arial"/>
+                <a:cs typeface="Arial"/>
+              </a:defRPr>
+            </a:lvl5pPr>
+            <a:lvl6pPr algn="l">
+              <a:defRPr sz="1950" b="1">
+                <a:solidFill>
+                  <a:srgbClr val="1D3B33"/>
+                </a:solidFill>
+                <a:latin typeface="Arial"/>
+                <a:ea typeface="Arial"/>
+                <a:cs typeface="Arial"/>
+              </a:defRPr>
+            </a:lvl6pPr>
+            <a:lvl7pPr algn="l">
+              <a:defRPr sz="1950" b="1">
+                <a:solidFill>
+                  <a:srgbClr val="1D3B33"/>
+                </a:solidFill>
+                <a:latin typeface="Arial"/>
+                <a:ea typeface="Arial"/>
+                <a:cs typeface="Arial"/>
+              </a:defRPr>
+            </a:lvl7pPr>
+            <a:lvl8pPr algn="l">
+              <a:defRPr sz="1950" b="1">
+                <a:solidFill>
+                  <a:srgbClr val="1D3B33"/>
+                </a:solidFill>
+                <a:latin typeface="Arial"/>
+                <a:ea typeface="Arial"/>
+                <a:cs typeface="Arial"/>
+              </a:defRPr>
+            </a:lvl8pPr>
+            <a:lvl9pPr algn="l">
+              <a:defRPr sz="1950" b="1">
+                <a:solidFill>
+                  <a:srgbClr val="1D3B33"/>
+                </a:solidFill>
+                <a:latin typeface="Arial"/>
+                <a:ea typeface="Arial"/>
+                <a:cs typeface="Arial"/>
+              </a:defRPr>
+            </a:lvl9pPr>
+          </a:lstStyle>
+          <a:p>
+            <a:pPr algn="ctr">
+              <a:defRPr sz="1950" b="1">
+                <a:solidFill>
+                  <a:srgbClr val="1D3B33"/>
+                </a:solidFill>
+                <a:latin typeface="Arial"/>
+                <a:ea typeface="Arial"/>
+                <a:cs typeface="Arial"/>
+              </a:defRPr>
+            </a:pPr>
+            <a:r>
+              <a:rPr sz="1950" b="1">
+                <a:solidFill>
+                  <a:srgbClr val="1D3B33"/>
+                </a:solidFill>
+                <a:latin typeface="Arial"/>
+                <a:ea typeface="Arial"/>
+                <a:cs typeface="Arial"/>
+              </a:rPr>
+              <a:t>6</a:t>
+            </a:r>
+          </a:p>
+        </p:txBody>
+      </p:sp>
+      <p:sp>
+        <p:nvSpPr>
+          <p:cNvPr id="15" name="Chart value 10"/>
+          <p:cNvSpPr>
+            <a:spLocks noGrp="1"/>
+          </p:cNvSpPr>
+          <p:nvPr/>
+        </p:nvSpPr>
+        <p:spPr>
+          <a:xfrm>
+            <a:off x="4972050" y="1714500"/>
+            <a:ext cx="400050" cy="342900"/>
+          </a:xfrm>
+          <a:prstGeom prst="rect">
+            <a:avLst/>
+          </a:prstGeom>
+          <a:noFill/>
+          <a:ln w="0">
+            <a:noFill/>
+          </a:ln>
+        </p:spPr>
+        <p:txBody>
+          <a:bodyPr wrap="square" lIns="0" tIns="0" rIns="0" bIns="0" anchor="ctr">
+            <a:noAutofit/>
+          </a:bodyPr>
+          <a:lstStyle>
+            <a:defPPr algn="l">
+              <a:defRPr sz="1950" b="1">
+                <a:solidFill>
+                  <a:srgbClr val="1D3B33"/>
+                </a:solidFill>
+                <a:latin typeface="Arial"/>
+                <a:ea typeface="Arial"/>
+                <a:cs typeface="Arial"/>
+              </a:defRPr>
+            </a:defPPr>
+            <a:lvl1pPr algn="l">
+              <a:defRPr sz="1950" b="1">
+                <a:solidFill>
+                  <a:srgbClr val="1D3B33"/>
+                </a:solidFill>
+                <a:latin typeface="Arial"/>
+                <a:ea typeface="Arial"/>
+                <a:cs typeface="Arial"/>
+              </a:defRPr>
+            </a:lvl1pPr>
+            <a:lvl2pPr algn="l">
+              <a:defRPr sz="1950" b="1">
+                <a:solidFill>
+                  <a:srgbClr val="1D3B33"/>
+                </a:solidFill>
+                <a:latin typeface="Arial"/>
+                <a:ea typeface="Arial"/>
+                <a:cs typeface="Arial"/>
+              </a:defRPr>
+            </a:lvl2pPr>
+            <a:lvl3pPr algn="l">
+              <a:defRPr sz="1950" b="1">
+                <a:solidFill>
+                  <a:srgbClr val="1D3B33"/>
+                </a:solidFill>
+                <a:latin typeface="Arial"/>
+                <a:ea typeface="Arial"/>
+                <a:cs typeface="Arial"/>
+              </a:defRPr>
+            </a:lvl3pPr>
+            <a:lvl4pPr algn="l">
+              <a:defRPr sz="1950" b="1">
+                <a:solidFill>
+                  <a:srgbClr val="1D3B33"/>
+                </a:solidFill>
+                <a:latin typeface="Arial"/>
+                <a:ea typeface="Arial"/>
+                <a:cs typeface="Arial"/>
+              </a:defRPr>
+            </a:lvl4pPr>
+            <a:lvl5pPr algn="l">
+              <a:defRPr sz="1950" b="1">
+                <a:solidFill>
+                  <a:srgbClr val="1D3B33"/>
+                </a:solidFill>
+                <a:latin typeface="Arial"/>
+                <a:ea typeface="Arial"/>
+                <a:cs typeface="Arial"/>
+              </a:defRPr>
+            </a:lvl5pPr>
+            <a:lvl6pPr algn="l">
+              <a:defRPr sz="1950" b="1">
+                <a:solidFill>
+                  <a:srgbClr val="1D3B33"/>
+                </a:solidFill>
+                <a:latin typeface="Arial"/>
+                <a:ea typeface="Arial"/>
+                <a:cs typeface="Arial"/>
+              </a:defRPr>
+            </a:lvl6pPr>
+            <a:lvl7pPr algn="l">
+              <a:defRPr sz="1950" b="1">
+                <a:solidFill>
+                  <a:srgbClr val="1D3B33"/>
+                </a:solidFill>
+                <a:latin typeface="Arial"/>
+                <a:ea typeface="Arial"/>
+                <a:cs typeface="Arial"/>
+              </a:defRPr>
+            </a:lvl7pPr>
+            <a:lvl8pPr algn="l">
+              <a:defRPr sz="1950" b="1">
+                <a:solidFill>
+                  <a:srgbClr val="1D3B33"/>
+                </a:solidFill>
+                <a:latin typeface="Arial"/>
+                <a:ea typeface="Arial"/>
+                <a:cs typeface="Arial"/>
+              </a:defRPr>
+            </a:lvl8pPr>
+            <a:lvl9pPr algn="l">
+              <a:defRPr sz="1950" b="1">
+                <a:solidFill>
+                  <a:srgbClr val="1D3B33"/>
+                </a:solidFill>
+                <a:latin typeface="Arial"/>
+                <a:ea typeface="Arial"/>
+                <a:cs typeface="Arial"/>
+              </a:defRPr>
+            </a:lvl9pPr>
+          </a:lstStyle>
+          <a:p>
+            <a:pPr algn="ctr">
+              <a:defRPr sz="1950" b="1">
+                <a:solidFill>
+                  <a:srgbClr val="1D3B33"/>
+                </a:solidFill>
+                <a:latin typeface="Arial"/>
+                <a:ea typeface="Arial"/>
+                <a:cs typeface="Arial"/>
+              </a:defRPr>
+            </a:pPr>
+            <a:r>
+              <a:rPr sz="1950" b="1">
+                <a:solidFill>
+                  <a:srgbClr val="1D3B33"/>
+                </a:solidFill>
+                <a:latin typeface="Arial"/>
+                <a:ea typeface="Arial"/>
+                <a:cs typeface="Arial"/>
+              </a:rPr>
+              <a:t>10</a:t>
+            </a:r>
+          </a:p>
+        </p:txBody>
+      </p:sp>
+      <p:sp>
+        <p:nvSpPr>
+          <p:cNvPr id="16" name="Chart value 10"/>
+          <p:cNvSpPr>
+            <a:spLocks noGrp="1"/>
+          </p:cNvSpPr>
+          <p:nvPr/>
+        </p:nvSpPr>
+        <p:spPr>
+          <a:xfrm>
+            <a:off x="6629400" y="1714500"/>
+            <a:ext cx="400050" cy="342900"/>
+          </a:xfrm>
+          <a:prstGeom prst="rect">
+            <a:avLst/>
+          </a:prstGeom>
+          <a:noFill/>
+          <a:ln w="0">
+            <a:noFill/>
+          </a:ln>
+        </p:spPr>
+        <p:txBody>
+          <a:bodyPr wrap="square" lIns="0" tIns="0" rIns="0" bIns="0" anchor="ctr">
+            <a:noAutofit/>
+          </a:bodyPr>
+          <a:lstStyle>
+            <a:defPPr algn="l">
+              <a:defRPr sz="1950" b="1">
+                <a:solidFill>
+                  <a:srgbClr val="1D3B33"/>
+                </a:solidFill>
+                <a:latin typeface="Arial"/>
+                <a:ea typeface="Arial"/>
+                <a:cs typeface="Arial"/>
+              </a:defRPr>
+            </a:defPPr>
+            <a:lvl1pPr algn="l">
+              <a:defRPr sz="1950" b="1">
+                <a:solidFill>
+                  <a:srgbClr val="1D3B33"/>
+                </a:solidFill>
+                <a:latin typeface="Arial"/>
+                <a:ea typeface="Arial"/>
+                <a:cs typeface="Arial"/>
+              </a:defRPr>
+            </a:lvl1pPr>
+            <a:lvl2pPr algn="l">
+              <a:defRPr sz="1950" b="1">
+                <a:solidFill>
+                  <a:srgbClr val="1D3B33"/>
+                </a:solidFill>
+                <a:latin typeface="Arial"/>
+                <a:ea typeface="Arial"/>
+                <a:cs typeface="Arial"/>
+              </a:defRPr>
+            </a:lvl2pPr>
+            <a:lvl3pPr algn="l">
+              <a:defRPr sz="1950" b="1">
+                <a:solidFill>
+                  <a:srgbClr val="1D3B33"/>
+                </a:solidFill>
+                <a:latin typeface="Arial"/>
+                <a:ea typeface="Arial"/>
+                <a:cs typeface="Arial"/>
+              </a:defRPr>
+            </a:lvl3pPr>
+            <a:lvl4pPr algn="l">
+              <a:defRPr sz="1950" b="1">
+                <a:solidFill>
+                  <a:srgbClr val="1D3B33"/>
+                </a:solidFill>
+                <a:latin typeface="Arial"/>
+                <a:ea typeface="Arial"/>
+                <a:cs typeface="Arial"/>
+              </a:defRPr>
+            </a:lvl4pPr>
+            <a:lvl5pPr algn="l">
+              <a:defRPr sz="1950" b="1">
+                <a:solidFill>
+                  <a:srgbClr val="1D3B33"/>
+                </a:solidFill>
+                <a:latin typeface="Arial"/>
+                <a:ea typeface="Arial"/>
+                <a:cs typeface="Arial"/>
+              </a:defRPr>
+            </a:lvl5pPr>
+            <a:lvl6pPr algn="l">
+              <a:defRPr sz="1950" b="1">
+                <a:solidFill>
+                  <a:srgbClr val="1D3B33"/>
+                </a:solidFill>
+                <a:latin typeface="Arial"/>
+                <a:ea typeface="Arial"/>
+                <a:cs typeface="Arial"/>
+              </a:defRPr>
+            </a:lvl6pPr>
+            <a:lvl7pPr algn="l">
+              <a:defRPr sz="1950" b="1">
+                <a:solidFill>
+                  <a:srgbClr val="1D3B33"/>
+                </a:solidFill>
+                <a:latin typeface="Arial"/>
+                <a:ea typeface="Arial"/>
+                <a:cs typeface="Arial"/>
+              </a:defRPr>
+            </a:lvl7pPr>
+            <a:lvl8pPr algn="l">
+              <a:defRPr sz="1950" b="1">
+                <a:solidFill>
+                  <a:srgbClr val="1D3B33"/>
+                </a:solidFill>
+                <a:latin typeface="Arial"/>
+                <a:ea typeface="Arial"/>
+                <a:cs typeface="Arial"/>
+              </a:defRPr>
+            </a:lvl8pPr>
+            <a:lvl9pPr algn="l">
+              <a:defRPr sz="1950" b="1">
+                <a:solidFill>
+                  <a:srgbClr val="1D3B33"/>
+                </a:solidFill>
+                <a:latin typeface="Arial"/>
+                <a:ea typeface="Arial"/>
+                <a:cs typeface="Arial"/>
+              </a:defRPr>
+            </a:lvl9pPr>
+          </a:lstStyle>
+          <a:p>
+            <a:pPr algn="ctr">
+              <a:defRPr sz="1950" b="1">
+                <a:solidFill>
+                  <a:srgbClr val="1D3B33"/>
+                </a:solidFill>
+                <a:latin typeface="Arial"/>
+                <a:ea typeface="Arial"/>
+                <a:cs typeface="Arial"/>
+              </a:defRPr>
+            </a:pPr>
+            <a:r>
+              <a:rPr sz="1950" b="1">
+                <a:solidFill>
+                  <a:srgbClr val="1D3B33"/>
+                </a:solidFill>
+                <a:latin typeface="Arial"/>
+                <a:ea typeface="Arial"/>
+                <a:cs typeface="Arial"/>
+              </a:rPr>
+              <a:t>10</a:t>
             </a:r>
           </a:p>
         </p:txBody>
@@ -22186,7 +22794,7 @@
     </p:spTree>
     <p:extLst>
       <p:ext uri="{BB962C8B-B14F-4D97-AF65-F5344CB8AC3E}">
-        <p14:creationId xmlns:p14="http://schemas.microsoft.com/office/powerpoint/2010/main" val="295759567"/>
+        <ns5:creationId val="295759567"/>
       </p:ext>
     </p:extLst>
   </p:cSld>

</xml_diff>